<commit_message>
Update Quantum Security Foundation and Quantum Risk Assessment presentations
</commit_message>
<xml_diff>
--- a/Presentations/5.Quantum Risk Assesment.pptx
+++ b/Presentations/5.Quantum Risk Assesment.pptx
@@ -6,28 +6,29 @@
     <p:sldMasterId id="2147483670" r:id="rId2"/>
   </p:sldMasterIdLst>
   <p:notesMasterIdLst>
-    <p:notesMasterId r:id="rId19"/>
+    <p:notesMasterId r:id="rId20"/>
   </p:notesMasterIdLst>
   <p:handoutMasterIdLst>
-    <p:handoutMasterId r:id="rId20"/>
+    <p:handoutMasterId r:id="rId21"/>
   </p:handoutMasterIdLst>
   <p:sldIdLst>
     <p:sldId id="141168164" r:id="rId3"/>
     <p:sldId id="141168166" r:id="rId4"/>
     <p:sldId id="141168160" r:id="rId5"/>
-    <p:sldId id="141168177" r:id="rId6"/>
-    <p:sldId id="141168184" r:id="rId7"/>
-    <p:sldId id="141168179" r:id="rId8"/>
-    <p:sldId id="141168167" r:id="rId9"/>
-    <p:sldId id="141168174" r:id="rId10"/>
-    <p:sldId id="141168173" r:id="rId11"/>
-    <p:sldId id="141168170" r:id="rId12"/>
-    <p:sldId id="141168171" r:id="rId13"/>
-    <p:sldId id="141168178" r:id="rId14"/>
-    <p:sldId id="141168172" r:id="rId15"/>
-    <p:sldId id="141168185" r:id="rId16"/>
-    <p:sldId id="141168168" r:id="rId17"/>
-    <p:sldId id="141168169" r:id="rId18"/>
+    <p:sldId id="141168186" r:id="rId6"/>
+    <p:sldId id="141168177" r:id="rId7"/>
+    <p:sldId id="141168184" r:id="rId8"/>
+    <p:sldId id="141168187" r:id="rId9"/>
+    <p:sldId id="141168167" r:id="rId10"/>
+    <p:sldId id="141168174" r:id="rId11"/>
+    <p:sldId id="141168173" r:id="rId12"/>
+    <p:sldId id="141168170" r:id="rId13"/>
+    <p:sldId id="141168171" r:id="rId14"/>
+    <p:sldId id="141168178" r:id="rId15"/>
+    <p:sldId id="141168172" r:id="rId16"/>
+    <p:sldId id="141168185" r:id="rId17"/>
+    <p:sldId id="141168168" r:id="rId18"/>
+    <p:sldId id="141168169" r:id="rId19"/>
   </p:sldIdLst>
   <p:sldSz cx="14630400" cy="8229600"/>
   <p:notesSz cx="6858000" cy="9144000"/>
@@ -337,7 +338,7 @@
           <a:p>
             <a:fld id="{25D3A1D4-C2F1-4FBA-9F37-B87A976340E2}" type="datetimeFigureOut">
               <a:rPr lang="en-US" smtClean="0"/>
-              <a:t>2/27/26</a:t>
+              <a:t>3/3/26</a:t>
             </a:fld>
             <a:endParaRPr lang="en-US"/>
           </a:p>
@@ -507,7 +508,7 @@
             <a:fld id="{5288BB53-F264-D84E-8876-073A512183CA}" type="datetimeFigureOut">
               <a:rPr lang="en-US" smtClean="0"/>
               <a:pPr/>
-              <a:t>2/27/26</a:t>
+              <a:t>3/3/26</a:t>
             </a:fld>
             <a:endParaRPr lang="en-US" dirty="0"/>
           </a:p>
@@ -3254,6 +3255,204 @@
   <p:cSld>
     <p:spTree>
       <p:nvGrpSpPr>
+        <p:cNvPr id="1" name="">
+          <a:extLst>
+            <a:ext uri="{FF2B5EF4-FFF2-40B4-BE49-F238E27FC236}">
+              <a16:creationId xmlns:a16="http://schemas.microsoft.com/office/drawing/2014/main" id="{E639B005-2EB7-718D-AE90-9F60889E9206}"/>
+            </a:ext>
+          </a:extLst>
+        </p:cNvPr>
+        <p:cNvGrpSpPr/>
+        <p:nvPr/>
+      </p:nvGrpSpPr>
+      <p:grpSpPr>
+        <a:xfrm>
+          <a:off x="0" y="0"/>
+          <a:ext cx="0" cy="0"/>
+          <a:chOff x="0" y="0"/>
+          <a:chExt cx="0" cy="0"/>
+        </a:xfrm>
+      </p:grpSpPr>
+      <p:sp>
+        <p:nvSpPr>
+          <p:cNvPr id="2" name="Title 1">
+            <a:extLst>
+              <a:ext uri="{FF2B5EF4-FFF2-40B4-BE49-F238E27FC236}">
+                <a16:creationId xmlns:a16="http://schemas.microsoft.com/office/drawing/2014/main" id="{F0E8912F-0E2B-D311-DDCD-92D9E8BB92B6}"/>
+              </a:ext>
+            </a:extLst>
+          </p:cNvPr>
+          <p:cNvSpPr>
+            <a:spLocks noGrp="1"/>
+          </p:cNvSpPr>
+          <p:nvPr>
+            <p:ph type="title"/>
+          </p:nvPr>
+        </p:nvSpPr>
+        <p:spPr/>
+        <p:txBody>
+          <a:bodyPr/>
+          <a:lstStyle/>
+          <a:p>
+            <a:pPr algn="ctr"/>
+            <a:r>
+              <a:rPr lang="en-US" sz="3200" b="1"/>
+              <a:t>Estimated Cryptographic Algorithm Count</a:t>
+            </a:r>
+            <a:br>
+              <a:rPr lang="en-US" sz="3200" b="1"/>
+            </a:br>
+            <a:r>
+              <a:rPr lang="en-US" sz="3200" b="1"/>
+              <a:t>(a.k.a. Crypto Inventory Typical Size/Volume) </a:t>
+            </a:r>
+            <a:br>
+              <a:rPr lang="en-US" sz="3200" b="1"/>
+            </a:br>
+            <a:endParaRPr lang="en-US" sz="3200" b="1" dirty="0"/>
+          </a:p>
+        </p:txBody>
+      </p:sp>
+      <p:sp>
+        <p:nvSpPr>
+          <p:cNvPr id="3" name="Content Placeholder 2">
+            <a:extLst>
+              <a:ext uri="{FF2B5EF4-FFF2-40B4-BE49-F238E27FC236}">
+                <a16:creationId xmlns:a16="http://schemas.microsoft.com/office/drawing/2014/main" id="{6FE50E3C-F7C7-FCF9-F57D-0818425404E5}"/>
+              </a:ext>
+            </a:extLst>
+          </p:cNvPr>
+          <p:cNvSpPr>
+            <a:spLocks noGrp="1"/>
+          </p:cNvSpPr>
+          <p:nvPr>
+            <p:ph idx="4294967295"/>
+          </p:nvPr>
+        </p:nvSpPr>
+        <p:spPr>
+          <a:xfrm>
+            <a:off x="609600" y="1828801"/>
+            <a:ext cx="8001000" cy="5257800"/>
+          </a:xfrm>
+        </p:spPr>
+        <p:txBody>
+          <a:bodyPr/>
+          <a:lstStyle/>
+          <a:p>
+            <a:pPr marL="514350" indent="-514350">
+              <a:buFont typeface="+mj-lt"/>
+              <a:buAutoNum type="arabicPeriod"/>
+            </a:pPr>
+            <a:r>
+              <a:rPr lang="en-US" sz="2800" b="1" dirty="0"/>
+              <a:t>Per Server/VM</a:t>
+            </a:r>
+            <a:r>
+              <a:rPr lang="en-US" sz="2800" dirty="0"/>
+              <a:t>: Each server or VM typically employs </a:t>
+            </a:r>
+            <a:r>
+              <a:rPr lang="en-US" sz="2800" b="1" dirty="0"/>
+              <a:t>20–50</a:t>
+            </a:r>
+            <a:r>
+              <a:rPr lang="en-US" sz="2800" dirty="0"/>
+              <a:t> distinct cryptographic algorithms. This includes algorithms used by the operating system, installed applications, and security services.</a:t>
+            </a:r>
+          </a:p>
+          <a:p>
+            <a:pPr marL="514350" indent="-514350">
+              <a:buFont typeface="+mj-lt"/>
+              <a:buAutoNum type="arabicPeriod"/>
+            </a:pPr>
+            <a:endParaRPr lang="en-US" sz="2800" dirty="0"/>
+          </a:p>
+          <a:p>
+            <a:pPr marL="514350" indent="-514350">
+              <a:buFont typeface="+mj-lt"/>
+              <a:buAutoNum type="arabicPeriod"/>
+            </a:pPr>
+            <a:r>
+              <a:rPr lang="en-US" sz="2800" dirty="0"/>
+              <a:t>For example, 100 Servers/VMs: Collectively, a data center with 100 servers or VMs might utilize </a:t>
+            </a:r>
+            <a:r>
+              <a:rPr lang="en-US" sz="2800" b="1" dirty="0"/>
+              <a:t>hundreds of unique algorithms </a:t>
+            </a:r>
+            <a:r>
+              <a:rPr lang="en-US" sz="2800" dirty="0"/>
+              <a:t>implementation, considering variations in configurations and applications.</a:t>
+            </a:r>
+            <a:endParaRPr lang="en-EG" sz="2800" dirty="0"/>
+          </a:p>
+        </p:txBody>
+      </p:sp>
+      <p:pic>
+        <p:nvPicPr>
+          <p:cNvPr id="4098" name="Picture 2" descr="Bibliometric Analysis of IoT Lightweight Cryptography">
+            <a:extLst>
+              <a:ext uri="{FF2B5EF4-FFF2-40B4-BE49-F238E27FC236}">
+                <a16:creationId xmlns:a16="http://schemas.microsoft.com/office/drawing/2014/main" id="{2F74B16D-BD53-0857-145F-DA030B6D9F2F}"/>
+              </a:ext>
+            </a:extLst>
+          </p:cNvPr>
+          <p:cNvPicPr>
+            <a:picLocks noChangeAspect="1" noChangeArrowheads="1"/>
+          </p:cNvPicPr>
+          <p:nvPr/>
+        </p:nvPicPr>
+        <p:blipFill>
+          <a:blip r:embed="rId2" cstate="email">
+            <a:extLst>
+              <a:ext uri="{28A0092B-C50C-407E-A947-70E740481C1C}">
+                <a14:useLocalDpi xmlns:a14="http://schemas.microsoft.com/office/drawing/2010/main"/>
+              </a:ext>
+            </a:extLst>
+          </a:blip>
+          <a:srcRect/>
+          <a:stretch>
+            <a:fillRect/>
+          </a:stretch>
+        </p:blipFill>
+        <p:spPr bwMode="auto">
+          <a:xfrm>
+            <a:off x="8680450" y="2133600"/>
+            <a:ext cx="5422900" cy="4114800"/>
+          </a:xfrm>
+          <a:prstGeom prst="rect">
+            <a:avLst/>
+          </a:prstGeom>
+          <a:noFill/>
+          <a:extLst>
+            <a:ext uri="{909E8E84-426E-40DD-AFC4-6F175D3DCCD1}">
+              <a14:hiddenFill xmlns:a14="http://schemas.microsoft.com/office/drawing/2010/main">
+                <a:solidFill>
+                  <a:srgbClr val="FFFFFF"/>
+                </a:solidFill>
+              </a14:hiddenFill>
+            </a:ext>
+          </a:extLst>
+        </p:spPr>
+      </p:pic>
+    </p:spTree>
+    <p:extLst>
+      <p:ext uri="{BB962C8B-B14F-4D97-AF65-F5344CB8AC3E}">
+        <p14:creationId xmlns:p14="http://schemas.microsoft.com/office/powerpoint/2010/main" val="3571843094"/>
+      </p:ext>
+    </p:extLst>
+  </p:cSld>
+  <p:clrMapOvr>
+    <a:masterClrMapping/>
+  </p:clrMapOvr>
+</p:sld>
+</file>
+
+<file path=ppt/slides/slide11.xml><?xml version="1.0" encoding="utf-8"?>
+<p:sld xmlns:a="http://schemas.openxmlformats.org/drawingml/2006/main" xmlns:r="http://schemas.openxmlformats.org/officeDocument/2006/relationships" xmlns:p="http://schemas.openxmlformats.org/presentationml/2006/main">
+  <p:cSld>
+    <p:spTree>
+      <p:nvGrpSpPr>
         <p:cNvPr id="1" name=""/>
         <p:cNvGrpSpPr/>
         <p:nvPr/>
@@ -3484,7 +3683,7 @@
 </p:sld>
 </file>
 
-<file path=ppt/slides/slide11.xml><?xml version="1.0" encoding="utf-8"?>
+<file path=ppt/slides/slide12.xml><?xml version="1.0" encoding="utf-8"?>
 <p:sld xmlns:a="http://schemas.openxmlformats.org/drawingml/2006/main" xmlns:r="http://schemas.openxmlformats.org/officeDocument/2006/relationships" xmlns:p="http://schemas.openxmlformats.org/presentationml/2006/main">
   <p:cSld>
     <p:spTree>
@@ -3669,7 +3868,7 @@
 </p:sld>
 </file>
 
-<file path=ppt/slides/slide12.xml><?xml version="1.0" encoding="utf-8"?>
+<file path=ppt/slides/slide13.xml><?xml version="1.0" encoding="utf-8"?>
 <p:sld xmlns:a="http://schemas.openxmlformats.org/drawingml/2006/main" xmlns:r="http://schemas.openxmlformats.org/officeDocument/2006/relationships" xmlns:p="http://schemas.openxmlformats.org/presentationml/2006/main">
   <p:cSld>
     <p:spTree>
@@ -5186,7 +5385,7 @@
 </p:sld>
 </file>
 
-<file path=ppt/slides/slide13.xml><?xml version="1.0" encoding="utf-8"?>
+<file path=ppt/slides/slide14.xml><?xml version="1.0" encoding="utf-8"?>
 <p:sld xmlns:a="http://schemas.openxmlformats.org/drawingml/2006/main" xmlns:r="http://schemas.openxmlformats.org/officeDocument/2006/relationships" xmlns:p="http://schemas.openxmlformats.org/presentationml/2006/main">
   <p:cSld>
     <p:spTree>
@@ -5376,7 +5575,7 @@
 </p:sld>
 </file>
 
-<file path=ppt/slides/slide14.xml><?xml version="1.0" encoding="utf-8"?>
+<file path=ppt/slides/slide15.xml><?xml version="1.0" encoding="utf-8"?>
 <p:sld xmlns:a="http://schemas.openxmlformats.org/drawingml/2006/main" xmlns:r="http://schemas.openxmlformats.org/officeDocument/2006/relationships" xmlns:p="http://schemas.openxmlformats.org/presentationml/2006/main">
   <p:cSld>
     <p:spTree>
@@ -5656,7 +5855,7 @@
 </p:sld>
 </file>
 
-<file path=ppt/slides/slide15.xml><?xml version="1.0" encoding="utf-8"?>
+<file path=ppt/slides/slide16.xml><?xml version="1.0" encoding="utf-8"?>
 <p:sld xmlns:a="http://schemas.openxmlformats.org/drawingml/2006/main" xmlns:r="http://schemas.openxmlformats.org/officeDocument/2006/relationships" xmlns:p="http://schemas.openxmlformats.org/presentationml/2006/main">
   <p:cSld>
     <p:spTree>
@@ -6152,7 +6351,7 @@
 </p:sld>
 </file>
 
-<file path=ppt/slides/slide16.xml><?xml version="1.0" encoding="utf-8"?>
+<file path=ppt/slides/slide17.xml><?xml version="1.0" encoding="utf-8"?>
 <p:sld xmlns:a="http://schemas.openxmlformats.org/drawingml/2006/main" xmlns:r="http://schemas.openxmlformats.org/officeDocument/2006/relationships" xmlns:p="http://schemas.openxmlformats.org/presentationml/2006/main">
   <p:cSld>
     <p:spTree>
@@ -8192,6 +8391,136 @@
         <p:cNvPr id="1" name="">
           <a:extLst>
             <a:ext uri="{FF2B5EF4-FFF2-40B4-BE49-F238E27FC236}">
+              <a16:creationId xmlns:a16="http://schemas.microsoft.com/office/drawing/2014/main" id="{DD4FD673-BBF5-18DA-9C17-0DF2FBAC550F}"/>
+            </a:ext>
+          </a:extLst>
+        </p:cNvPr>
+        <p:cNvGrpSpPr/>
+        <p:nvPr/>
+      </p:nvGrpSpPr>
+      <p:grpSpPr>
+        <a:xfrm>
+          <a:off x="0" y="0"/>
+          <a:ext cx="0" cy="0"/>
+          <a:chOff x="0" y="0"/>
+          <a:chExt cx="0" cy="0"/>
+        </a:xfrm>
+      </p:grpSpPr>
+      <p:sp>
+        <p:nvSpPr>
+          <p:cNvPr id="2" name="TextShape 1">
+            <a:extLst>
+              <a:ext uri="{FF2B5EF4-FFF2-40B4-BE49-F238E27FC236}">
+                <a16:creationId xmlns:a16="http://schemas.microsoft.com/office/drawing/2014/main" id="{EF5BDDCB-C3DE-12AC-1EAA-1866CD7F8C84}"/>
+              </a:ext>
+            </a:extLst>
+          </p:cNvPr>
+          <p:cNvSpPr txBox="1"/>
+          <p:nvPr/>
+        </p:nvSpPr>
+        <p:spPr>
+          <a:xfrm>
+            <a:off x="456075" y="228600"/>
+            <a:ext cx="13718250" cy="865381"/>
+          </a:xfrm>
+          <a:prstGeom prst="rect">
+            <a:avLst/>
+          </a:prstGeom>
+          <a:noFill/>
+          <a:ln>
+            <a:noFill/>
+          </a:ln>
+        </p:spPr>
+        <p:txBody>
+          <a:bodyPr lIns="0" tIns="0" rIns="0" bIns="0">
+            <a:noAutofit/>
+          </a:bodyPr>
+          <a:lstStyle/>
+          <a:p>
+            <a:pPr>
+              <a:lnSpc>
+                <a:spcPct val="90000"/>
+              </a:lnSpc>
+              <a:defRPr/>
+            </a:pPr>
+            <a:r>
+              <a:rPr lang="en-US" sz="3840" b="1" spc="-2" dirty="0">
+                <a:solidFill>
+                  <a:schemeClr val="accent2"/>
+                </a:solidFill>
+                <a:latin typeface="Calibri" panose="020F0502020204030204" pitchFamily="34" charset="0"/>
+                <a:ea typeface="IBM Plex Sans"/>
+                <a:cs typeface="Calibri" panose="020F0502020204030204" pitchFamily="34" charset="0"/>
+              </a:rPr>
+              <a:t>Quantum Threat Models</a:t>
+            </a:r>
+            <a:endParaRPr lang="en-US" sz="3840" spc="-2" dirty="0">
+              <a:solidFill>
+                <a:schemeClr val="accent2"/>
+              </a:solidFill>
+              <a:latin typeface="Calibri" panose="020F0502020204030204" pitchFamily="34" charset="0"/>
+              <a:cs typeface="Calibri" panose="020F0502020204030204" pitchFamily="34" charset="0"/>
+            </a:endParaRPr>
+          </a:p>
+        </p:txBody>
+      </p:sp>
+      <p:pic>
+        <p:nvPicPr>
+          <p:cNvPr id="5" name="Picture 4">
+            <a:extLst>
+              <a:ext uri="{FF2B5EF4-FFF2-40B4-BE49-F238E27FC236}">
+                <a16:creationId xmlns:a16="http://schemas.microsoft.com/office/drawing/2014/main" id="{8E242639-068F-754E-4840-E60A4C7C5A22}"/>
+              </a:ext>
+            </a:extLst>
+          </p:cNvPr>
+          <p:cNvPicPr>
+            <a:picLocks noChangeAspect="1"/>
+          </p:cNvPicPr>
+          <p:nvPr/>
+        </p:nvPicPr>
+        <p:blipFill>
+          <a:blip r:embed="rId2" cstate="email">
+            <a:extLst>
+              <a:ext uri="{28A0092B-C50C-407E-A947-70E740481C1C}">
+                <a14:useLocalDpi xmlns:a14="http://schemas.microsoft.com/office/drawing/2010/main"/>
+              </a:ext>
+            </a:extLst>
+          </a:blip>
+          <a:stretch>
+            <a:fillRect/>
+          </a:stretch>
+        </p:blipFill>
+        <p:spPr>
+          <a:xfrm>
+            <a:off x="228599" y="838200"/>
+            <a:ext cx="14114117" cy="6858000"/>
+          </a:xfrm>
+          <a:prstGeom prst="rect">
+            <a:avLst/>
+          </a:prstGeom>
+        </p:spPr>
+      </p:pic>
+    </p:spTree>
+    <p:extLst>
+      <p:ext uri="{BB962C8B-B14F-4D97-AF65-F5344CB8AC3E}">
+        <p14:creationId xmlns:p14="http://schemas.microsoft.com/office/powerpoint/2010/main" val="822086115"/>
+      </p:ext>
+    </p:extLst>
+  </p:cSld>
+  <p:clrMapOvr>
+    <a:masterClrMapping/>
+  </p:clrMapOvr>
+</p:sld>
+</file>
+
+<file path=ppt/slides/slide5.xml><?xml version="1.0" encoding="utf-8"?>
+<p:sld xmlns:a="http://schemas.openxmlformats.org/drawingml/2006/main" xmlns:r="http://schemas.openxmlformats.org/officeDocument/2006/relationships" xmlns:p="http://schemas.openxmlformats.org/presentationml/2006/main">
+  <p:cSld>
+    <p:spTree>
+      <p:nvGrpSpPr>
+        <p:cNvPr id="1" name="">
+          <a:extLst>
+            <a:ext uri="{FF2B5EF4-FFF2-40B4-BE49-F238E27FC236}">
               <a16:creationId xmlns:a16="http://schemas.microsoft.com/office/drawing/2014/main" id="{54E2015B-87C3-E9CA-DD91-B6B0B50CBF58}"/>
             </a:ext>
           </a:extLst>
@@ -10195,7 +10524,7 @@
 </p:sld>
 </file>
 
-<file path=ppt/slides/slide5.xml><?xml version="1.0" encoding="utf-8"?>
+<file path=ppt/slides/slide6.xml><?xml version="1.0" encoding="utf-8"?>
 <p:sld xmlns:a="http://schemas.openxmlformats.org/drawingml/2006/main" xmlns:r="http://schemas.openxmlformats.org/officeDocument/2006/relationships" xmlns:p="http://schemas.openxmlformats.org/presentationml/2006/main">
   <p:cSld>
     <p:spTree>
@@ -11864,7 +12193,7 @@
 </p:sld>
 </file>
 
-<file path=ppt/slides/slide6.xml><?xml version="1.0" encoding="utf-8"?>
+<file path=ppt/slides/slide7.xml><?xml version="1.0" encoding="utf-8"?>
 <p:sld xmlns:a="http://schemas.openxmlformats.org/drawingml/2006/main" xmlns:r="http://schemas.openxmlformats.org/officeDocument/2006/relationships" xmlns:p="http://schemas.openxmlformats.org/presentationml/2006/main">
   <p:cSld>
     <p:spTree>
@@ -11927,17 +12256,17 @@
             <a:r>
               <a:rPr lang="en-US" sz="3840" b="1" spc="-2" dirty="0">
                 <a:solidFill>
-                  <a:srgbClr val="000000"/>
+                  <a:schemeClr val="accent2"/>
                 </a:solidFill>
                 <a:latin typeface="Calibri" panose="020F0502020204030204" pitchFamily="34" charset="0"/>
                 <a:ea typeface="IBM Plex Sans"/>
                 <a:cs typeface="Calibri" panose="020F0502020204030204" pitchFamily="34" charset="0"/>
               </a:rPr>
-              <a:t>QSRI: Quantum-Safe Readiness Index Assessment</a:t>
+              <a:t>QSRI: Quantum-Security Readiness Index Assessment</a:t>
             </a:r>
             <a:endParaRPr lang="en-US" sz="3840" spc="-2" dirty="0">
               <a:solidFill>
-                <a:srgbClr val="000000"/>
+                <a:schemeClr val="accent2"/>
               </a:solidFill>
               <a:latin typeface="Calibri" panose="020F0502020204030204" pitchFamily="34" charset="0"/>
               <a:cs typeface="Calibri" panose="020F0502020204030204" pitchFamily="34" charset="0"/>
@@ -11947,10 +12276,10 @@
       </p:sp>
       <p:pic>
         <p:nvPicPr>
-          <p:cNvPr id="4" name="Picture 3">
+          <p:cNvPr id="5" name="Picture 4">
             <a:extLst>
               <a:ext uri="{FF2B5EF4-FFF2-40B4-BE49-F238E27FC236}">
-                <a16:creationId xmlns:a16="http://schemas.microsoft.com/office/drawing/2014/main" id="{125ECBDA-30C9-E53E-8D23-BF24A5B04DA4}"/>
+                <a16:creationId xmlns:a16="http://schemas.microsoft.com/office/drawing/2014/main" id="{704FE2F3-9C49-0726-B38F-D3A4971C71E3}"/>
               </a:ext>
             </a:extLst>
           </p:cNvPr>
@@ -11973,8 +12302,116 @@
         </p:blipFill>
         <p:spPr>
           <a:xfrm>
-            <a:off x="228600" y="1071496"/>
-            <a:ext cx="14173200" cy="6703183"/>
+            <a:off x="10833100" y="838201"/>
+            <a:ext cx="3797300" cy="6858000"/>
+          </a:xfrm>
+          <a:prstGeom prst="rect">
+            <a:avLst/>
+          </a:prstGeom>
+        </p:spPr>
+      </p:pic>
+      <p:pic>
+        <p:nvPicPr>
+          <p:cNvPr id="6" name="Picture 5">
+            <a:extLst>
+              <a:ext uri="{FF2B5EF4-FFF2-40B4-BE49-F238E27FC236}">
+                <a16:creationId xmlns:a16="http://schemas.microsoft.com/office/drawing/2014/main" id="{9363C290-DB35-9ADE-6903-6D587707EBD7}"/>
+              </a:ext>
+            </a:extLst>
+          </p:cNvPr>
+          <p:cNvPicPr>
+            <a:picLocks noChangeAspect="1"/>
+          </p:cNvPicPr>
+          <p:nvPr/>
+        </p:nvPicPr>
+        <p:blipFill>
+          <a:blip r:embed="rId3" cstate="email">
+            <a:extLst>
+              <a:ext uri="{28A0092B-C50C-407E-A947-70E740481C1C}">
+                <a14:useLocalDpi xmlns:a14="http://schemas.microsoft.com/office/drawing/2010/main"/>
+              </a:ext>
+            </a:extLst>
+          </a:blip>
+          <a:stretch>
+            <a:fillRect/>
+          </a:stretch>
+        </p:blipFill>
+        <p:spPr>
+          <a:xfrm>
+            <a:off x="7924800" y="4342557"/>
+            <a:ext cx="2859116" cy="3353643"/>
+          </a:xfrm>
+          <a:prstGeom prst="rect">
+            <a:avLst/>
+          </a:prstGeom>
+        </p:spPr>
+      </p:pic>
+      <p:pic>
+        <p:nvPicPr>
+          <p:cNvPr id="7" name="Picture 6">
+            <a:extLst>
+              <a:ext uri="{FF2B5EF4-FFF2-40B4-BE49-F238E27FC236}">
+                <a16:creationId xmlns:a16="http://schemas.microsoft.com/office/drawing/2014/main" id="{C484CE17-293B-898B-F4B3-A5FEE947AD35}"/>
+              </a:ext>
+            </a:extLst>
+          </p:cNvPr>
+          <p:cNvPicPr>
+            <a:picLocks noChangeAspect="1"/>
+          </p:cNvPicPr>
+          <p:nvPr/>
+        </p:nvPicPr>
+        <p:blipFill>
+          <a:blip r:embed="rId4" cstate="email">
+            <a:extLst>
+              <a:ext uri="{28A0092B-C50C-407E-A947-70E740481C1C}">
+                <a14:useLocalDpi xmlns:a14="http://schemas.microsoft.com/office/drawing/2010/main"/>
+              </a:ext>
+            </a:extLst>
+          </a:blip>
+          <a:stretch>
+            <a:fillRect/>
+          </a:stretch>
+        </p:blipFill>
+        <p:spPr>
+          <a:xfrm>
+            <a:off x="7907703" y="840699"/>
+            <a:ext cx="2893310" cy="3501858"/>
+          </a:xfrm>
+          <a:prstGeom prst="rect">
+            <a:avLst/>
+          </a:prstGeom>
+        </p:spPr>
+      </p:pic>
+      <p:pic>
+        <p:nvPicPr>
+          <p:cNvPr id="8" name="Picture 7">
+            <a:extLst>
+              <a:ext uri="{FF2B5EF4-FFF2-40B4-BE49-F238E27FC236}">
+                <a16:creationId xmlns:a16="http://schemas.microsoft.com/office/drawing/2014/main" id="{054B9FB9-16B0-CFF8-4FF4-33426189EEBB}"/>
+              </a:ext>
+            </a:extLst>
+          </p:cNvPr>
+          <p:cNvPicPr>
+            <a:picLocks noChangeAspect="1"/>
+          </p:cNvPicPr>
+          <p:nvPr/>
+        </p:nvPicPr>
+        <p:blipFill>
+          <a:blip r:embed="rId5" cstate="email">
+            <a:extLst>
+              <a:ext uri="{28A0092B-C50C-407E-A947-70E740481C1C}">
+                <a14:useLocalDpi xmlns:a14="http://schemas.microsoft.com/office/drawing/2010/main"/>
+              </a:ext>
+            </a:extLst>
+          </a:blip>
+          <a:stretch>
+            <a:fillRect/>
+          </a:stretch>
+        </p:blipFill>
+        <p:spPr>
+          <a:xfrm>
+            <a:off x="103216" y="838201"/>
+            <a:ext cx="7772400" cy="6858000"/>
           </a:xfrm>
           <a:prstGeom prst="rect">
             <a:avLst/>
@@ -11984,7 +12421,7 @@
     </p:spTree>
     <p:extLst>
       <p:ext uri="{BB962C8B-B14F-4D97-AF65-F5344CB8AC3E}">
-        <p14:creationId xmlns:p14="http://schemas.microsoft.com/office/powerpoint/2010/main" val="1714632780"/>
+        <p14:creationId xmlns:p14="http://schemas.microsoft.com/office/powerpoint/2010/main" val="1547602878"/>
       </p:ext>
     </p:extLst>
   </p:cSld>
@@ -11994,7 +12431,7 @@
 </p:sld>
 </file>
 
-<file path=ppt/slides/slide7.xml><?xml version="1.0" encoding="utf-8"?>
+<file path=ppt/slides/slide8.xml><?xml version="1.0" encoding="utf-8"?>
 <p:sld xmlns:a="http://schemas.openxmlformats.org/drawingml/2006/main" xmlns:r="http://schemas.openxmlformats.org/officeDocument/2006/relationships" xmlns:p="http://schemas.openxmlformats.org/presentationml/2006/main">
   <p:cSld>
     <p:spTree>
@@ -12380,7 +12817,7 @@
 </p:sld>
 </file>
 
-<file path=ppt/slides/slide8.xml><?xml version="1.0" encoding="utf-8"?>
+<file path=ppt/slides/slide9.xml><?xml version="1.0" encoding="utf-8"?>
 <p:sld xmlns:a="http://schemas.openxmlformats.org/drawingml/2006/main" xmlns:r="http://schemas.openxmlformats.org/officeDocument/2006/relationships" xmlns:p="http://schemas.openxmlformats.org/presentationml/2006/main">
   <p:cSld>
     <p:spTree>
@@ -12609,204 +13046,6 @@
     <p:extLst>
       <p:ext uri="{BB962C8B-B14F-4D97-AF65-F5344CB8AC3E}">
         <p14:creationId xmlns:p14="http://schemas.microsoft.com/office/powerpoint/2010/main" val="2906025844"/>
-      </p:ext>
-    </p:extLst>
-  </p:cSld>
-  <p:clrMapOvr>
-    <a:masterClrMapping/>
-  </p:clrMapOvr>
-</p:sld>
-</file>
-
-<file path=ppt/slides/slide9.xml><?xml version="1.0" encoding="utf-8"?>
-<p:sld xmlns:a="http://schemas.openxmlformats.org/drawingml/2006/main" xmlns:r="http://schemas.openxmlformats.org/officeDocument/2006/relationships" xmlns:p="http://schemas.openxmlformats.org/presentationml/2006/main">
-  <p:cSld>
-    <p:spTree>
-      <p:nvGrpSpPr>
-        <p:cNvPr id="1" name="">
-          <a:extLst>
-            <a:ext uri="{FF2B5EF4-FFF2-40B4-BE49-F238E27FC236}">
-              <a16:creationId xmlns:a16="http://schemas.microsoft.com/office/drawing/2014/main" id="{E639B005-2EB7-718D-AE90-9F60889E9206}"/>
-            </a:ext>
-          </a:extLst>
-        </p:cNvPr>
-        <p:cNvGrpSpPr/>
-        <p:nvPr/>
-      </p:nvGrpSpPr>
-      <p:grpSpPr>
-        <a:xfrm>
-          <a:off x="0" y="0"/>
-          <a:ext cx="0" cy="0"/>
-          <a:chOff x="0" y="0"/>
-          <a:chExt cx="0" cy="0"/>
-        </a:xfrm>
-      </p:grpSpPr>
-      <p:sp>
-        <p:nvSpPr>
-          <p:cNvPr id="2" name="Title 1">
-            <a:extLst>
-              <a:ext uri="{FF2B5EF4-FFF2-40B4-BE49-F238E27FC236}">
-                <a16:creationId xmlns:a16="http://schemas.microsoft.com/office/drawing/2014/main" id="{F0E8912F-0E2B-D311-DDCD-92D9E8BB92B6}"/>
-              </a:ext>
-            </a:extLst>
-          </p:cNvPr>
-          <p:cNvSpPr>
-            <a:spLocks noGrp="1"/>
-          </p:cNvSpPr>
-          <p:nvPr>
-            <p:ph type="title"/>
-          </p:nvPr>
-        </p:nvSpPr>
-        <p:spPr/>
-        <p:txBody>
-          <a:bodyPr/>
-          <a:lstStyle/>
-          <a:p>
-            <a:pPr algn="ctr"/>
-            <a:r>
-              <a:rPr lang="en-US" sz="3200" b="1"/>
-              <a:t>Estimated Cryptographic Algorithm Count</a:t>
-            </a:r>
-            <a:br>
-              <a:rPr lang="en-US" sz="3200" b="1"/>
-            </a:br>
-            <a:r>
-              <a:rPr lang="en-US" sz="3200" b="1"/>
-              <a:t>(a.k.a. Crypto Inventory Typical Size/Volume) </a:t>
-            </a:r>
-            <a:br>
-              <a:rPr lang="en-US" sz="3200" b="1"/>
-            </a:br>
-            <a:endParaRPr lang="en-US" sz="3200" b="1" dirty="0"/>
-          </a:p>
-        </p:txBody>
-      </p:sp>
-      <p:sp>
-        <p:nvSpPr>
-          <p:cNvPr id="3" name="Content Placeholder 2">
-            <a:extLst>
-              <a:ext uri="{FF2B5EF4-FFF2-40B4-BE49-F238E27FC236}">
-                <a16:creationId xmlns:a16="http://schemas.microsoft.com/office/drawing/2014/main" id="{6FE50E3C-F7C7-FCF9-F57D-0818425404E5}"/>
-              </a:ext>
-            </a:extLst>
-          </p:cNvPr>
-          <p:cNvSpPr>
-            <a:spLocks noGrp="1"/>
-          </p:cNvSpPr>
-          <p:nvPr>
-            <p:ph idx="4294967295"/>
-          </p:nvPr>
-        </p:nvSpPr>
-        <p:spPr>
-          <a:xfrm>
-            <a:off x="609600" y="1828801"/>
-            <a:ext cx="8001000" cy="5257800"/>
-          </a:xfrm>
-        </p:spPr>
-        <p:txBody>
-          <a:bodyPr/>
-          <a:lstStyle/>
-          <a:p>
-            <a:pPr marL="514350" indent="-514350">
-              <a:buFont typeface="+mj-lt"/>
-              <a:buAutoNum type="arabicPeriod"/>
-            </a:pPr>
-            <a:r>
-              <a:rPr lang="en-US" sz="2800" b="1" dirty="0"/>
-              <a:t>Per Server/VM</a:t>
-            </a:r>
-            <a:r>
-              <a:rPr lang="en-US" sz="2800" dirty="0"/>
-              <a:t>: Each server or VM typically employs </a:t>
-            </a:r>
-            <a:r>
-              <a:rPr lang="en-US" sz="2800" b="1" dirty="0"/>
-              <a:t>20–50</a:t>
-            </a:r>
-            <a:r>
-              <a:rPr lang="en-US" sz="2800" dirty="0"/>
-              <a:t> distinct cryptographic algorithms. This includes algorithms used by the operating system, installed applications, and security services.</a:t>
-            </a:r>
-          </a:p>
-          <a:p>
-            <a:pPr marL="514350" indent="-514350">
-              <a:buFont typeface="+mj-lt"/>
-              <a:buAutoNum type="arabicPeriod"/>
-            </a:pPr>
-            <a:endParaRPr lang="en-US" sz="2800" dirty="0"/>
-          </a:p>
-          <a:p>
-            <a:pPr marL="514350" indent="-514350">
-              <a:buFont typeface="+mj-lt"/>
-              <a:buAutoNum type="arabicPeriod"/>
-            </a:pPr>
-            <a:r>
-              <a:rPr lang="en-US" sz="2800" dirty="0"/>
-              <a:t>For example, 100 Servers/VMs: Collectively, a data center with 100 servers or VMs might utilize </a:t>
-            </a:r>
-            <a:r>
-              <a:rPr lang="en-US" sz="2800" b="1" dirty="0"/>
-              <a:t>hundreds of unique algorithms </a:t>
-            </a:r>
-            <a:r>
-              <a:rPr lang="en-US" sz="2800" dirty="0"/>
-              <a:t>implementation, considering variations in configurations and applications.</a:t>
-            </a:r>
-            <a:endParaRPr lang="en-EG" sz="2800" dirty="0"/>
-          </a:p>
-        </p:txBody>
-      </p:sp>
-      <p:pic>
-        <p:nvPicPr>
-          <p:cNvPr id="4098" name="Picture 2" descr="Bibliometric Analysis of IoT Lightweight Cryptography">
-            <a:extLst>
-              <a:ext uri="{FF2B5EF4-FFF2-40B4-BE49-F238E27FC236}">
-                <a16:creationId xmlns:a16="http://schemas.microsoft.com/office/drawing/2014/main" id="{2F74B16D-BD53-0857-145F-DA030B6D9F2F}"/>
-              </a:ext>
-            </a:extLst>
-          </p:cNvPr>
-          <p:cNvPicPr>
-            <a:picLocks noChangeAspect="1" noChangeArrowheads="1"/>
-          </p:cNvPicPr>
-          <p:nvPr/>
-        </p:nvPicPr>
-        <p:blipFill>
-          <a:blip r:embed="rId2" cstate="email">
-            <a:extLst>
-              <a:ext uri="{28A0092B-C50C-407E-A947-70E740481C1C}">
-                <a14:useLocalDpi xmlns:a14="http://schemas.microsoft.com/office/drawing/2010/main"/>
-              </a:ext>
-            </a:extLst>
-          </a:blip>
-          <a:srcRect/>
-          <a:stretch>
-            <a:fillRect/>
-          </a:stretch>
-        </p:blipFill>
-        <p:spPr bwMode="auto">
-          <a:xfrm>
-            <a:off x="8680450" y="2133600"/>
-            <a:ext cx="5422900" cy="4114800"/>
-          </a:xfrm>
-          <a:prstGeom prst="rect">
-            <a:avLst/>
-          </a:prstGeom>
-          <a:noFill/>
-          <a:extLst>
-            <a:ext uri="{909E8E84-426E-40DD-AFC4-6F175D3DCCD1}">
-              <a14:hiddenFill xmlns:a14="http://schemas.microsoft.com/office/drawing/2010/main">
-                <a:solidFill>
-                  <a:srgbClr val="FFFFFF"/>
-                </a:solidFill>
-              </a14:hiddenFill>
-            </a:ext>
-          </a:extLst>
-        </p:spPr>
-      </p:pic>
-    </p:spTree>
-    <p:extLst>
-      <p:ext uri="{BB962C8B-B14F-4D97-AF65-F5344CB8AC3E}">
-        <p14:creationId xmlns:p14="http://schemas.microsoft.com/office/powerpoint/2010/main" val="3571843094"/>
       </p:ext>
     </p:extLst>
   </p:cSld>

</xml_diff>

<commit_message>
Update Quantum Risk Assessment presentation
</commit_message>
<xml_diff>
--- a/Presentations/5.Quantum Risk Assesment.pptx
+++ b/Presentations/5.Quantum Risk Assesment.pptx
@@ -15,8 +15,8 @@
     <p:sldId id="141168164" r:id="rId3"/>
     <p:sldId id="141168166" r:id="rId4"/>
     <p:sldId id="141168160" r:id="rId5"/>
-    <p:sldId id="141168186" r:id="rId6"/>
-    <p:sldId id="141168177" r:id="rId7"/>
+    <p:sldId id="141168177" r:id="rId6"/>
+    <p:sldId id="141168186" r:id="rId7"/>
     <p:sldId id="141168184" r:id="rId8"/>
     <p:sldId id="141168187" r:id="rId9"/>
     <p:sldId id="141168167" r:id="rId10"/>
@@ -338,7 +338,7 @@
           <a:p>
             <a:fld id="{25D3A1D4-C2F1-4FBA-9F37-B87A976340E2}" type="datetimeFigureOut">
               <a:rPr lang="en-US" smtClean="0"/>
-              <a:t>3/3/26</a:t>
+              <a:t>3/12/26</a:t>
             </a:fld>
             <a:endParaRPr lang="en-US"/>
           </a:p>
@@ -508,7 +508,7 @@
             <a:fld id="{5288BB53-F264-D84E-8876-073A512183CA}" type="datetimeFigureOut">
               <a:rPr lang="en-US" smtClean="0"/>
               <a:pPr/>
-              <a:t>3/3/26</a:t>
+              <a:t>3/12/26</a:t>
             </a:fld>
             <a:endParaRPr lang="en-US" dirty="0"/>
           </a:p>
@@ -1333,6 +1333,165 @@
           </a:p>
         </p:txBody>
       </p:sp>
+      <p:sp>
+        <p:nvSpPr>
+          <p:cNvPr id="2" name="Slide Number Placeholder 2">
+            <a:extLst>
+              <a:ext uri="{FF2B5EF4-FFF2-40B4-BE49-F238E27FC236}">
+                <a16:creationId xmlns:a16="http://schemas.microsoft.com/office/drawing/2014/main" id="{9014E83F-520A-4CD5-0E53-3C0111C0784C}"/>
+              </a:ext>
+            </a:extLst>
+          </p:cNvPr>
+          <p:cNvSpPr txBox="1">
+            <a:spLocks/>
+          </p:cNvSpPr>
+          <p:nvPr userDrawn="1"/>
+        </p:nvSpPr>
+        <p:spPr>
+          <a:xfrm>
+            <a:off x="454859" y="7714211"/>
+            <a:ext cx="2022333" cy="515389"/>
+          </a:xfrm>
+          <a:prstGeom prst="rect">
+            <a:avLst/>
+          </a:prstGeom>
+        </p:spPr>
+        <p:txBody>
+          <a:bodyPr lIns="0" tIns="0" rIns="0" bIns="0" anchor="ctr"/>
+          <a:lstStyle>
+            <a:defPPr>
+              <a:defRPr lang="en-US"/>
+            </a:defPPr>
+            <a:lvl1pPr marL="0" algn="l" defTabSz="685800" rtl="0" eaLnBrk="1" latinLnBrk="0" hangingPunct="1">
+              <a:defRPr sz="1350" kern="1200">
+                <a:solidFill>
+                  <a:schemeClr val="bg2"/>
+                </a:solidFill>
+                <a:latin typeface="+mn-lt"/>
+                <a:ea typeface="+mn-ea"/>
+                <a:cs typeface="+mn-cs"/>
+              </a:defRPr>
+            </a:lvl1pPr>
+            <a:lvl2pPr marL="342900" algn="l" defTabSz="685800" rtl="0" eaLnBrk="1" latinLnBrk="0" hangingPunct="1">
+              <a:defRPr sz="1350" kern="1200">
+                <a:solidFill>
+                  <a:schemeClr val="tx1"/>
+                </a:solidFill>
+                <a:latin typeface="+mn-lt"/>
+                <a:ea typeface="+mn-ea"/>
+                <a:cs typeface="+mn-cs"/>
+              </a:defRPr>
+            </a:lvl2pPr>
+            <a:lvl3pPr marL="685800" algn="l" defTabSz="685800" rtl="0" eaLnBrk="1" latinLnBrk="0" hangingPunct="1">
+              <a:defRPr sz="1350" kern="1200">
+                <a:solidFill>
+                  <a:schemeClr val="tx1"/>
+                </a:solidFill>
+                <a:latin typeface="+mn-lt"/>
+                <a:ea typeface="+mn-ea"/>
+                <a:cs typeface="+mn-cs"/>
+              </a:defRPr>
+            </a:lvl3pPr>
+            <a:lvl4pPr marL="1028700" algn="l" defTabSz="685800" rtl="0" eaLnBrk="1" latinLnBrk="0" hangingPunct="1">
+              <a:defRPr sz="1350" kern="1200">
+                <a:solidFill>
+                  <a:schemeClr val="tx1"/>
+                </a:solidFill>
+                <a:latin typeface="+mn-lt"/>
+                <a:ea typeface="+mn-ea"/>
+                <a:cs typeface="+mn-cs"/>
+              </a:defRPr>
+            </a:lvl4pPr>
+            <a:lvl5pPr marL="1371600" algn="l" defTabSz="685800" rtl="0" eaLnBrk="1" latinLnBrk="0" hangingPunct="1">
+              <a:defRPr sz="1350" kern="1200">
+                <a:solidFill>
+                  <a:schemeClr val="tx1"/>
+                </a:solidFill>
+                <a:latin typeface="+mn-lt"/>
+                <a:ea typeface="+mn-ea"/>
+                <a:cs typeface="+mn-cs"/>
+              </a:defRPr>
+            </a:lvl5pPr>
+            <a:lvl6pPr marL="1714500" algn="l" defTabSz="685800" rtl="0" eaLnBrk="1" latinLnBrk="0" hangingPunct="1">
+              <a:defRPr sz="1350" kern="1200">
+                <a:solidFill>
+                  <a:schemeClr val="tx1"/>
+                </a:solidFill>
+                <a:latin typeface="+mn-lt"/>
+                <a:ea typeface="+mn-ea"/>
+                <a:cs typeface="+mn-cs"/>
+              </a:defRPr>
+            </a:lvl6pPr>
+            <a:lvl7pPr marL="2057400" algn="l" defTabSz="685800" rtl="0" eaLnBrk="1" latinLnBrk="0" hangingPunct="1">
+              <a:defRPr sz="1350" kern="1200">
+                <a:solidFill>
+                  <a:schemeClr val="tx1"/>
+                </a:solidFill>
+                <a:latin typeface="+mn-lt"/>
+                <a:ea typeface="+mn-ea"/>
+                <a:cs typeface="+mn-cs"/>
+              </a:defRPr>
+            </a:lvl7pPr>
+            <a:lvl8pPr marL="2400300" algn="l" defTabSz="685800" rtl="0" eaLnBrk="1" latinLnBrk="0" hangingPunct="1">
+              <a:defRPr sz="1350" kern="1200">
+                <a:solidFill>
+                  <a:schemeClr val="tx1"/>
+                </a:solidFill>
+                <a:latin typeface="+mn-lt"/>
+                <a:ea typeface="+mn-ea"/>
+                <a:cs typeface="+mn-cs"/>
+              </a:defRPr>
+            </a:lvl8pPr>
+            <a:lvl9pPr marL="2743200" algn="l" defTabSz="685800" rtl="0" eaLnBrk="1" latinLnBrk="0" hangingPunct="1">
+              <a:defRPr sz="1350" kern="1200">
+                <a:solidFill>
+                  <a:schemeClr val="tx1"/>
+                </a:solidFill>
+                <a:latin typeface="+mn-lt"/>
+                <a:ea typeface="+mn-ea"/>
+                <a:cs typeface="+mn-cs"/>
+              </a:defRPr>
+            </a:lvl9pPr>
+          </a:lstStyle>
+          <a:p>
+            <a:pPr algn="l"/>
+            <a:r>
+              <a:rPr lang="en-US" sz="1920" b="0" i="0" dirty="0">
+                <a:solidFill>
+                  <a:schemeClr val="bg2"/>
+                </a:solidFill>
+                <a:latin typeface="IBM Plex Sans" charset="0"/>
+                <a:ea typeface="IBM Plex Sans" charset="0"/>
+                <a:cs typeface="IBM Plex Sans" charset="0"/>
+              </a:rPr>
+              <a:t>Page </a:t>
+            </a:r>
+            <a:fld id="{3FD999D4-B456-9943-89B7-30D56181CE18}" type="slidenum">
+              <a:rPr lang="en-US" sz="1920" b="0" i="0" smtClean="0">
+                <a:solidFill>
+                  <a:schemeClr val="bg2"/>
+                </a:solidFill>
+                <a:latin typeface="IBM Plex Sans" charset="0"/>
+                <a:ea typeface="IBM Plex Sans" charset="0"/>
+                <a:cs typeface="IBM Plex Sans" charset="0"/>
+              </a:rPr>
+              <a:pPr algn="l"/>
+              <a:t>‹#›</a:t>
+            </a:fld>
+            <a:r>
+              <a:rPr lang="en-US" sz="1920" b="0" i="0" dirty="0">
+                <a:solidFill>
+                  <a:schemeClr val="bg2"/>
+                </a:solidFill>
+                <a:latin typeface="IBM Plex Sans" charset="0"/>
+                <a:ea typeface="IBM Plex Sans" charset="0"/>
+                <a:cs typeface="IBM Plex Sans" charset="0"/>
+              </a:rPr>
+              <a:t> </a:t>
+            </a:r>
+          </a:p>
+        </p:txBody>
+      </p:sp>
     </p:spTree>
     <p:extLst>
       <p:ext uri="{BB962C8B-B14F-4D97-AF65-F5344CB8AC3E}">
@@ -2049,6 +2208,165 @@
               <a:ea typeface="IBM Plex Sans" charset="0"/>
               <a:cs typeface="Calibri" panose="020F0502020204030204" pitchFamily="34" charset="0"/>
             </a:endParaRPr>
+          </a:p>
+        </p:txBody>
+      </p:sp>
+      <p:sp>
+        <p:nvSpPr>
+          <p:cNvPr id="4" name="Slide Number Placeholder 2">
+            <a:extLst>
+              <a:ext uri="{FF2B5EF4-FFF2-40B4-BE49-F238E27FC236}">
+                <a16:creationId xmlns:a16="http://schemas.microsoft.com/office/drawing/2014/main" id="{59600BEE-0DDA-C4E8-9DEB-7A1A735B88CF}"/>
+              </a:ext>
+            </a:extLst>
+          </p:cNvPr>
+          <p:cNvSpPr txBox="1">
+            <a:spLocks/>
+          </p:cNvSpPr>
+          <p:nvPr userDrawn="1"/>
+        </p:nvSpPr>
+        <p:spPr>
+          <a:xfrm>
+            <a:off x="454859" y="7714211"/>
+            <a:ext cx="2022333" cy="515389"/>
+          </a:xfrm>
+          <a:prstGeom prst="rect">
+            <a:avLst/>
+          </a:prstGeom>
+        </p:spPr>
+        <p:txBody>
+          <a:bodyPr lIns="0" tIns="0" rIns="0" bIns="0" anchor="ctr"/>
+          <a:lstStyle>
+            <a:defPPr>
+              <a:defRPr lang="en-US"/>
+            </a:defPPr>
+            <a:lvl1pPr marL="0" algn="l" defTabSz="685800" rtl="0" eaLnBrk="1" latinLnBrk="0" hangingPunct="1">
+              <a:defRPr sz="1350" kern="1200">
+                <a:solidFill>
+                  <a:schemeClr val="bg2"/>
+                </a:solidFill>
+                <a:latin typeface="+mn-lt"/>
+                <a:ea typeface="+mn-ea"/>
+                <a:cs typeface="+mn-cs"/>
+              </a:defRPr>
+            </a:lvl1pPr>
+            <a:lvl2pPr marL="342900" algn="l" defTabSz="685800" rtl="0" eaLnBrk="1" latinLnBrk="0" hangingPunct="1">
+              <a:defRPr sz="1350" kern="1200">
+                <a:solidFill>
+                  <a:schemeClr val="tx1"/>
+                </a:solidFill>
+                <a:latin typeface="+mn-lt"/>
+                <a:ea typeface="+mn-ea"/>
+                <a:cs typeface="+mn-cs"/>
+              </a:defRPr>
+            </a:lvl2pPr>
+            <a:lvl3pPr marL="685800" algn="l" defTabSz="685800" rtl="0" eaLnBrk="1" latinLnBrk="0" hangingPunct="1">
+              <a:defRPr sz="1350" kern="1200">
+                <a:solidFill>
+                  <a:schemeClr val="tx1"/>
+                </a:solidFill>
+                <a:latin typeface="+mn-lt"/>
+                <a:ea typeface="+mn-ea"/>
+                <a:cs typeface="+mn-cs"/>
+              </a:defRPr>
+            </a:lvl3pPr>
+            <a:lvl4pPr marL="1028700" algn="l" defTabSz="685800" rtl="0" eaLnBrk="1" latinLnBrk="0" hangingPunct="1">
+              <a:defRPr sz="1350" kern="1200">
+                <a:solidFill>
+                  <a:schemeClr val="tx1"/>
+                </a:solidFill>
+                <a:latin typeface="+mn-lt"/>
+                <a:ea typeface="+mn-ea"/>
+                <a:cs typeface="+mn-cs"/>
+              </a:defRPr>
+            </a:lvl4pPr>
+            <a:lvl5pPr marL="1371600" algn="l" defTabSz="685800" rtl="0" eaLnBrk="1" latinLnBrk="0" hangingPunct="1">
+              <a:defRPr sz="1350" kern="1200">
+                <a:solidFill>
+                  <a:schemeClr val="tx1"/>
+                </a:solidFill>
+                <a:latin typeface="+mn-lt"/>
+                <a:ea typeface="+mn-ea"/>
+                <a:cs typeface="+mn-cs"/>
+              </a:defRPr>
+            </a:lvl5pPr>
+            <a:lvl6pPr marL="1714500" algn="l" defTabSz="685800" rtl="0" eaLnBrk="1" latinLnBrk="0" hangingPunct="1">
+              <a:defRPr sz="1350" kern="1200">
+                <a:solidFill>
+                  <a:schemeClr val="tx1"/>
+                </a:solidFill>
+                <a:latin typeface="+mn-lt"/>
+                <a:ea typeface="+mn-ea"/>
+                <a:cs typeface="+mn-cs"/>
+              </a:defRPr>
+            </a:lvl6pPr>
+            <a:lvl7pPr marL="2057400" algn="l" defTabSz="685800" rtl="0" eaLnBrk="1" latinLnBrk="0" hangingPunct="1">
+              <a:defRPr sz="1350" kern="1200">
+                <a:solidFill>
+                  <a:schemeClr val="tx1"/>
+                </a:solidFill>
+                <a:latin typeface="+mn-lt"/>
+                <a:ea typeface="+mn-ea"/>
+                <a:cs typeface="+mn-cs"/>
+              </a:defRPr>
+            </a:lvl7pPr>
+            <a:lvl8pPr marL="2400300" algn="l" defTabSz="685800" rtl="0" eaLnBrk="1" latinLnBrk="0" hangingPunct="1">
+              <a:defRPr sz="1350" kern="1200">
+                <a:solidFill>
+                  <a:schemeClr val="tx1"/>
+                </a:solidFill>
+                <a:latin typeface="+mn-lt"/>
+                <a:ea typeface="+mn-ea"/>
+                <a:cs typeface="+mn-cs"/>
+              </a:defRPr>
+            </a:lvl8pPr>
+            <a:lvl9pPr marL="2743200" algn="l" defTabSz="685800" rtl="0" eaLnBrk="1" latinLnBrk="0" hangingPunct="1">
+              <a:defRPr sz="1350" kern="1200">
+                <a:solidFill>
+                  <a:schemeClr val="tx1"/>
+                </a:solidFill>
+                <a:latin typeface="+mn-lt"/>
+                <a:ea typeface="+mn-ea"/>
+                <a:cs typeface="+mn-cs"/>
+              </a:defRPr>
+            </a:lvl9pPr>
+          </a:lstStyle>
+          <a:p>
+            <a:pPr algn="l"/>
+            <a:r>
+              <a:rPr lang="en-US" sz="1920" b="0" i="0" dirty="0">
+                <a:solidFill>
+                  <a:schemeClr val="tx1"/>
+                </a:solidFill>
+                <a:latin typeface="IBM Plex Sans" charset="0"/>
+                <a:ea typeface="IBM Plex Sans" charset="0"/>
+                <a:cs typeface="IBM Plex Sans" charset="0"/>
+              </a:rPr>
+              <a:t>Page </a:t>
+            </a:r>
+            <a:fld id="{3FD999D4-B456-9943-89B7-30D56181CE18}" type="slidenum">
+              <a:rPr lang="en-US" sz="1920" b="0" i="0" smtClean="0">
+                <a:solidFill>
+                  <a:schemeClr val="tx1"/>
+                </a:solidFill>
+                <a:latin typeface="IBM Plex Sans" charset="0"/>
+                <a:ea typeface="IBM Plex Sans" charset="0"/>
+                <a:cs typeface="IBM Plex Sans" charset="0"/>
+              </a:rPr>
+              <a:pPr algn="l"/>
+              <a:t>‹#›</a:t>
+            </a:fld>
+            <a:r>
+              <a:rPr lang="en-US" sz="1920" b="0" i="0" dirty="0">
+                <a:solidFill>
+                  <a:schemeClr val="tx1"/>
+                </a:solidFill>
+                <a:latin typeface="IBM Plex Sans" charset="0"/>
+                <a:ea typeface="IBM Plex Sans" charset="0"/>
+                <a:cs typeface="IBM Plex Sans" charset="0"/>
+              </a:rPr>
+              <a:t> </a:t>
+            </a:r>
           </a:p>
         </p:txBody>
       </p:sp>
@@ -2509,6 +2827,165 @@
           </a:fontRef>
         </p:style>
       </p:cxnSp>
+      <p:sp>
+        <p:nvSpPr>
+          <p:cNvPr id="4" name="Slide Number Placeholder 2">
+            <a:extLst>
+              <a:ext uri="{FF2B5EF4-FFF2-40B4-BE49-F238E27FC236}">
+                <a16:creationId xmlns:a16="http://schemas.microsoft.com/office/drawing/2014/main" id="{F9BEFB92-6D08-A8E4-8DD7-2D8EF02FF760}"/>
+              </a:ext>
+            </a:extLst>
+          </p:cNvPr>
+          <p:cNvSpPr txBox="1">
+            <a:spLocks/>
+          </p:cNvSpPr>
+          <p:nvPr userDrawn="1"/>
+        </p:nvSpPr>
+        <p:spPr>
+          <a:xfrm>
+            <a:off x="454859" y="7714211"/>
+            <a:ext cx="2022333" cy="515389"/>
+          </a:xfrm>
+          <a:prstGeom prst="rect">
+            <a:avLst/>
+          </a:prstGeom>
+        </p:spPr>
+        <p:txBody>
+          <a:bodyPr lIns="0" tIns="0" rIns="0" bIns="0" anchor="ctr"/>
+          <a:lstStyle>
+            <a:defPPr>
+              <a:defRPr lang="en-US"/>
+            </a:defPPr>
+            <a:lvl1pPr marL="0" algn="l" defTabSz="685800" rtl="0" eaLnBrk="1" latinLnBrk="0" hangingPunct="1">
+              <a:defRPr sz="1350" kern="1200">
+                <a:solidFill>
+                  <a:schemeClr val="bg2"/>
+                </a:solidFill>
+                <a:latin typeface="+mn-lt"/>
+                <a:ea typeface="+mn-ea"/>
+                <a:cs typeface="+mn-cs"/>
+              </a:defRPr>
+            </a:lvl1pPr>
+            <a:lvl2pPr marL="342900" algn="l" defTabSz="685800" rtl="0" eaLnBrk="1" latinLnBrk="0" hangingPunct="1">
+              <a:defRPr sz="1350" kern="1200">
+                <a:solidFill>
+                  <a:schemeClr val="tx1"/>
+                </a:solidFill>
+                <a:latin typeface="+mn-lt"/>
+                <a:ea typeface="+mn-ea"/>
+                <a:cs typeface="+mn-cs"/>
+              </a:defRPr>
+            </a:lvl2pPr>
+            <a:lvl3pPr marL="685800" algn="l" defTabSz="685800" rtl="0" eaLnBrk="1" latinLnBrk="0" hangingPunct="1">
+              <a:defRPr sz="1350" kern="1200">
+                <a:solidFill>
+                  <a:schemeClr val="tx1"/>
+                </a:solidFill>
+                <a:latin typeface="+mn-lt"/>
+                <a:ea typeface="+mn-ea"/>
+                <a:cs typeface="+mn-cs"/>
+              </a:defRPr>
+            </a:lvl3pPr>
+            <a:lvl4pPr marL="1028700" algn="l" defTabSz="685800" rtl="0" eaLnBrk="1" latinLnBrk="0" hangingPunct="1">
+              <a:defRPr sz="1350" kern="1200">
+                <a:solidFill>
+                  <a:schemeClr val="tx1"/>
+                </a:solidFill>
+                <a:latin typeface="+mn-lt"/>
+                <a:ea typeface="+mn-ea"/>
+                <a:cs typeface="+mn-cs"/>
+              </a:defRPr>
+            </a:lvl4pPr>
+            <a:lvl5pPr marL="1371600" algn="l" defTabSz="685800" rtl="0" eaLnBrk="1" latinLnBrk="0" hangingPunct="1">
+              <a:defRPr sz="1350" kern="1200">
+                <a:solidFill>
+                  <a:schemeClr val="tx1"/>
+                </a:solidFill>
+                <a:latin typeface="+mn-lt"/>
+                <a:ea typeface="+mn-ea"/>
+                <a:cs typeface="+mn-cs"/>
+              </a:defRPr>
+            </a:lvl5pPr>
+            <a:lvl6pPr marL="1714500" algn="l" defTabSz="685800" rtl="0" eaLnBrk="1" latinLnBrk="0" hangingPunct="1">
+              <a:defRPr sz="1350" kern="1200">
+                <a:solidFill>
+                  <a:schemeClr val="tx1"/>
+                </a:solidFill>
+                <a:latin typeface="+mn-lt"/>
+                <a:ea typeface="+mn-ea"/>
+                <a:cs typeface="+mn-cs"/>
+              </a:defRPr>
+            </a:lvl6pPr>
+            <a:lvl7pPr marL="2057400" algn="l" defTabSz="685800" rtl="0" eaLnBrk="1" latinLnBrk="0" hangingPunct="1">
+              <a:defRPr sz="1350" kern="1200">
+                <a:solidFill>
+                  <a:schemeClr val="tx1"/>
+                </a:solidFill>
+                <a:latin typeface="+mn-lt"/>
+                <a:ea typeface="+mn-ea"/>
+                <a:cs typeface="+mn-cs"/>
+              </a:defRPr>
+            </a:lvl7pPr>
+            <a:lvl8pPr marL="2400300" algn="l" defTabSz="685800" rtl="0" eaLnBrk="1" latinLnBrk="0" hangingPunct="1">
+              <a:defRPr sz="1350" kern="1200">
+                <a:solidFill>
+                  <a:schemeClr val="tx1"/>
+                </a:solidFill>
+                <a:latin typeface="+mn-lt"/>
+                <a:ea typeface="+mn-ea"/>
+                <a:cs typeface="+mn-cs"/>
+              </a:defRPr>
+            </a:lvl8pPr>
+            <a:lvl9pPr marL="2743200" algn="l" defTabSz="685800" rtl="0" eaLnBrk="1" latinLnBrk="0" hangingPunct="1">
+              <a:defRPr sz="1350" kern="1200">
+                <a:solidFill>
+                  <a:schemeClr val="tx1"/>
+                </a:solidFill>
+                <a:latin typeface="+mn-lt"/>
+                <a:ea typeface="+mn-ea"/>
+                <a:cs typeface="+mn-cs"/>
+              </a:defRPr>
+            </a:lvl9pPr>
+          </a:lstStyle>
+          <a:p>
+            <a:pPr algn="l"/>
+            <a:r>
+              <a:rPr lang="en-US" sz="1920" b="0" i="0" dirty="0">
+                <a:solidFill>
+                  <a:schemeClr val="tx1"/>
+                </a:solidFill>
+                <a:latin typeface="IBM Plex Sans" charset="0"/>
+                <a:ea typeface="IBM Plex Sans" charset="0"/>
+                <a:cs typeface="IBM Plex Sans" charset="0"/>
+              </a:rPr>
+              <a:t>Page </a:t>
+            </a:r>
+            <a:fld id="{3FD999D4-B456-9943-89B7-30D56181CE18}" type="slidenum">
+              <a:rPr lang="en-US" sz="1920" b="0" i="0" smtClean="0">
+                <a:solidFill>
+                  <a:schemeClr val="tx1"/>
+                </a:solidFill>
+                <a:latin typeface="IBM Plex Sans" charset="0"/>
+                <a:ea typeface="IBM Plex Sans" charset="0"/>
+                <a:cs typeface="IBM Plex Sans" charset="0"/>
+              </a:rPr>
+              <a:pPr algn="l"/>
+              <a:t>‹#›</a:t>
+            </a:fld>
+            <a:r>
+              <a:rPr lang="en-US" sz="1920" b="0" i="0" dirty="0">
+                <a:solidFill>
+                  <a:schemeClr val="tx1"/>
+                </a:solidFill>
+                <a:latin typeface="IBM Plex Sans" charset="0"/>
+                <a:ea typeface="IBM Plex Sans" charset="0"/>
+                <a:cs typeface="IBM Plex Sans" charset="0"/>
+              </a:rPr>
+              <a:t> </a:t>
+            </a:r>
+          </a:p>
+        </p:txBody>
+      </p:sp>
     </p:spTree>
     <p:extLst>
       <p:ext uri="{BB962C8B-B14F-4D97-AF65-F5344CB8AC3E}">
@@ -8391,136 +8868,6 @@
         <p:cNvPr id="1" name="">
           <a:extLst>
             <a:ext uri="{FF2B5EF4-FFF2-40B4-BE49-F238E27FC236}">
-              <a16:creationId xmlns:a16="http://schemas.microsoft.com/office/drawing/2014/main" id="{DD4FD673-BBF5-18DA-9C17-0DF2FBAC550F}"/>
-            </a:ext>
-          </a:extLst>
-        </p:cNvPr>
-        <p:cNvGrpSpPr/>
-        <p:nvPr/>
-      </p:nvGrpSpPr>
-      <p:grpSpPr>
-        <a:xfrm>
-          <a:off x="0" y="0"/>
-          <a:ext cx="0" cy="0"/>
-          <a:chOff x="0" y="0"/>
-          <a:chExt cx="0" cy="0"/>
-        </a:xfrm>
-      </p:grpSpPr>
-      <p:sp>
-        <p:nvSpPr>
-          <p:cNvPr id="2" name="TextShape 1">
-            <a:extLst>
-              <a:ext uri="{FF2B5EF4-FFF2-40B4-BE49-F238E27FC236}">
-                <a16:creationId xmlns:a16="http://schemas.microsoft.com/office/drawing/2014/main" id="{EF5BDDCB-C3DE-12AC-1EAA-1866CD7F8C84}"/>
-              </a:ext>
-            </a:extLst>
-          </p:cNvPr>
-          <p:cNvSpPr txBox="1"/>
-          <p:nvPr/>
-        </p:nvSpPr>
-        <p:spPr>
-          <a:xfrm>
-            <a:off x="456075" y="228600"/>
-            <a:ext cx="13718250" cy="865381"/>
-          </a:xfrm>
-          <a:prstGeom prst="rect">
-            <a:avLst/>
-          </a:prstGeom>
-          <a:noFill/>
-          <a:ln>
-            <a:noFill/>
-          </a:ln>
-        </p:spPr>
-        <p:txBody>
-          <a:bodyPr lIns="0" tIns="0" rIns="0" bIns="0">
-            <a:noAutofit/>
-          </a:bodyPr>
-          <a:lstStyle/>
-          <a:p>
-            <a:pPr>
-              <a:lnSpc>
-                <a:spcPct val="90000"/>
-              </a:lnSpc>
-              <a:defRPr/>
-            </a:pPr>
-            <a:r>
-              <a:rPr lang="en-US" sz="3840" b="1" spc="-2" dirty="0">
-                <a:solidFill>
-                  <a:schemeClr val="accent2"/>
-                </a:solidFill>
-                <a:latin typeface="Calibri" panose="020F0502020204030204" pitchFamily="34" charset="0"/>
-                <a:ea typeface="IBM Plex Sans"/>
-                <a:cs typeface="Calibri" panose="020F0502020204030204" pitchFamily="34" charset="0"/>
-              </a:rPr>
-              <a:t>Quantum Threat Models</a:t>
-            </a:r>
-            <a:endParaRPr lang="en-US" sz="3840" spc="-2" dirty="0">
-              <a:solidFill>
-                <a:schemeClr val="accent2"/>
-              </a:solidFill>
-              <a:latin typeface="Calibri" panose="020F0502020204030204" pitchFamily="34" charset="0"/>
-              <a:cs typeface="Calibri" panose="020F0502020204030204" pitchFamily="34" charset="0"/>
-            </a:endParaRPr>
-          </a:p>
-        </p:txBody>
-      </p:sp>
-      <p:pic>
-        <p:nvPicPr>
-          <p:cNvPr id="5" name="Picture 4">
-            <a:extLst>
-              <a:ext uri="{FF2B5EF4-FFF2-40B4-BE49-F238E27FC236}">
-                <a16:creationId xmlns:a16="http://schemas.microsoft.com/office/drawing/2014/main" id="{8E242639-068F-754E-4840-E60A4C7C5A22}"/>
-              </a:ext>
-            </a:extLst>
-          </p:cNvPr>
-          <p:cNvPicPr>
-            <a:picLocks noChangeAspect="1"/>
-          </p:cNvPicPr>
-          <p:nvPr/>
-        </p:nvPicPr>
-        <p:blipFill>
-          <a:blip r:embed="rId2" cstate="email">
-            <a:extLst>
-              <a:ext uri="{28A0092B-C50C-407E-A947-70E740481C1C}">
-                <a14:useLocalDpi xmlns:a14="http://schemas.microsoft.com/office/drawing/2010/main"/>
-              </a:ext>
-            </a:extLst>
-          </a:blip>
-          <a:stretch>
-            <a:fillRect/>
-          </a:stretch>
-        </p:blipFill>
-        <p:spPr>
-          <a:xfrm>
-            <a:off x="228599" y="838200"/>
-            <a:ext cx="14114117" cy="6858000"/>
-          </a:xfrm>
-          <a:prstGeom prst="rect">
-            <a:avLst/>
-          </a:prstGeom>
-        </p:spPr>
-      </p:pic>
-    </p:spTree>
-    <p:extLst>
-      <p:ext uri="{BB962C8B-B14F-4D97-AF65-F5344CB8AC3E}">
-        <p14:creationId xmlns:p14="http://schemas.microsoft.com/office/powerpoint/2010/main" val="822086115"/>
-      </p:ext>
-    </p:extLst>
-  </p:cSld>
-  <p:clrMapOvr>
-    <a:masterClrMapping/>
-  </p:clrMapOvr>
-</p:sld>
-</file>
-
-<file path=ppt/slides/slide5.xml><?xml version="1.0" encoding="utf-8"?>
-<p:sld xmlns:a="http://schemas.openxmlformats.org/drawingml/2006/main" xmlns:r="http://schemas.openxmlformats.org/officeDocument/2006/relationships" xmlns:p="http://schemas.openxmlformats.org/presentationml/2006/main">
-  <p:cSld>
-    <p:spTree>
-      <p:nvGrpSpPr>
-        <p:cNvPr id="1" name="">
-          <a:extLst>
-            <a:ext uri="{FF2B5EF4-FFF2-40B4-BE49-F238E27FC236}">
               <a16:creationId xmlns:a16="http://schemas.microsoft.com/office/drawing/2014/main" id="{54E2015B-87C3-E9CA-DD91-B6B0B50CBF58}"/>
             </a:ext>
           </a:extLst>
@@ -10524,6 +10871,136 @@
 </p:sld>
 </file>
 
+<file path=ppt/slides/slide5.xml><?xml version="1.0" encoding="utf-8"?>
+<p:sld xmlns:a="http://schemas.openxmlformats.org/drawingml/2006/main" xmlns:r="http://schemas.openxmlformats.org/officeDocument/2006/relationships" xmlns:p="http://schemas.openxmlformats.org/presentationml/2006/main">
+  <p:cSld>
+    <p:spTree>
+      <p:nvGrpSpPr>
+        <p:cNvPr id="1" name="">
+          <a:extLst>
+            <a:ext uri="{FF2B5EF4-FFF2-40B4-BE49-F238E27FC236}">
+              <a16:creationId xmlns:a16="http://schemas.microsoft.com/office/drawing/2014/main" id="{DD4FD673-BBF5-18DA-9C17-0DF2FBAC550F}"/>
+            </a:ext>
+          </a:extLst>
+        </p:cNvPr>
+        <p:cNvGrpSpPr/>
+        <p:nvPr/>
+      </p:nvGrpSpPr>
+      <p:grpSpPr>
+        <a:xfrm>
+          <a:off x="0" y="0"/>
+          <a:ext cx="0" cy="0"/>
+          <a:chOff x="0" y="0"/>
+          <a:chExt cx="0" cy="0"/>
+        </a:xfrm>
+      </p:grpSpPr>
+      <p:sp>
+        <p:nvSpPr>
+          <p:cNvPr id="2" name="TextShape 1">
+            <a:extLst>
+              <a:ext uri="{FF2B5EF4-FFF2-40B4-BE49-F238E27FC236}">
+                <a16:creationId xmlns:a16="http://schemas.microsoft.com/office/drawing/2014/main" id="{EF5BDDCB-C3DE-12AC-1EAA-1866CD7F8C84}"/>
+              </a:ext>
+            </a:extLst>
+          </p:cNvPr>
+          <p:cNvSpPr txBox="1"/>
+          <p:nvPr/>
+        </p:nvSpPr>
+        <p:spPr>
+          <a:xfrm>
+            <a:off x="456075" y="228600"/>
+            <a:ext cx="13718250" cy="865381"/>
+          </a:xfrm>
+          <a:prstGeom prst="rect">
+            <a:avLst/>
+          </a:prstGeom>
+          <a:noFill/>
+          <a:ln>
+            <a:noFill/>
+          </a:ln>
+        </p:spPr>
+        <p:txBody>
+          <a:bodyPr lIns="0" tIns="0" rIns="0" bIns="0">
+            <a:noAutofit/>
+          </a:bodyPr>
+          <a:lstStyle/>
+          <a:p>
+            <a:pPr>
+              <a:lnSpc>
+                <a:spcPct val="90000"/>
+              </a:lnSpc>
+              <a:defRPr/>
+            </a:pPr>
+            <a:r>
+              <a:rPr lang="en-US" sz="3840" b="1" spc="-2" dirty="0">
+                <a:solidFill>
+                  <a:schemeClr val="accent2"/>
+                </a:solidFill>
+                <a:latin typeface="Calibri" panose="020F0502020204030204" pitchFamily="34" charset="0"/>
+                <a:ea typeface="IBM Plex Sans"/>
+                <a:cs typeface="Calibri" panose="020F0502020204030204" pitchFamily="34" charset="0"/>
+              </a:rPr>
+              <a:t>Quantum Threat Models</a:t>
+            </a:r>
+            <a:endParaRPr lang="en-US" sz="3840" spc="-2" dirty="0">
+              <a:solidFill>
+                <a:schemeClr val="accent2"/>
+              </a:solidFill>
+              <a:latin typeface="Calibri" panose="020F0502020204030204" pitchFamily="34" charset="0"/>
+              <a:cs typeface="Calibri" panose="020F0502020204030204" pitchFamily="34" charset="0"/>
+            </a:endParaRPr>
+          </a:p>
+        </p:txBody>
+      </p:sp>
+      <p:pic>
+        <p:nvPicPr>
+          <p:cNvPr id="5" name="Picture 4">
+            <a:extLst>
+              <a:ext uri="{FF2B5EF4-FFF2-40B4-BE49-F238E27FC236}">
+                <a16:creationId xmlns:a16="http://schemas.microsoft.com/office/drawing/2014/main" id="{8E242639-068F-754E-4840-E60A4C7C5A22}"/>
+              </a:ext>
+            </a:extLst>
+          </p:cNvPr>
+          <p:cNvPicPr>
+            <a:picLocks noChangeAspect="1"/>
+          </p:cNvPicPr>
+          <p:nvPr/>
+        </p:nvPicPr>
+        <p:blipFill>
+          <a:blip r:embed="rId2" cstate="email">
+            <a:extLst>
+              <a:ext uri="{28A0092B-C50C-407E-A947-70E740481C1C}">
+                <a14:useLocalDpi xmlns:a14="http://schemas.microsoft.com/office/drawing/2010/main"/>
+              </a:ext>
+            </a:extLst>
+          </a:blip>
+          <a:stretch>
+            <a:fillRect/>
+          </a:stretch>
+        </p:blipFill>
+        <p:spPr>
+          <a:xfrm>
+            <a:off x="228599" y="838200"/>
+            <a:ext cx="14114117" cy="6858000"/>
+          </a:xfrm>
+          <a:prstGeom prst="rect">
+            <a:avLst/>
+          </a:prstGeom>
+        </p:spPr>
+      </p:pic>
+    </p:spTree>
+    <p:extLst>
+      <p:ext uri="{BB962C8B-B14F-4D97-AF65-F5344CB8AC3E}">
+        <p14:creationId xmlns:p14="http://schemas.microsoft.com/office/powerpoint/2010/main" val="822086115"/>
+      </p:ext>
+    </p:extLst>
+  </p:cSld>
+  <p:clrMapOvr>
+    <a:masterClrMapping/>
+  </p:clrMapOvr>
+</p:sld>
+</file>
+
 <file path=ppt/slides/slide6.xml><?xml version="1.0" encoding="utf-8"?>
 <p:sld xmlns:a="http://schemas.openxmlformats.org/drawingml/2006/main" xmlns:r="http://schemas.openxmlformats.org/officeDocument/2006/relationships" xmlns:p="http://schemas.openxmlformats.org/presentationml/2006/main">
   <p:cSld>
@@ -10635,11 +11112,17 @@
           <p:cNvGraphicFramePr>
             <a:graphicFrameLocks noGrp="1"/>
           </p:cNvGraphicFramePr>
-          <p:nvPr/>
+          <p:nvPr>
+            <p:extLst>
+              <p:ext uri="{D42A27DB-BD31-4B8C-83A1-F6EECF244321}">
+                <p14:modId xmlns:p14="http://schemas.microsoft.com/office/powerpoint/2010/main" val="2517811213"/>
+              </p:ext>
+            </p:extLst>
+          </p:nvPr>
         </p:nvGraphicFramePr>
         <p:xfrm>
           <a:off x="457200" y="664316"/>
-          <a:ext cx="13487400" cy="7412884"/>
+          <a:ext cx="13487400" cy="7156675"/>
         </p:xfrm>
         <a:graphic>
           <a:graphicData uri="http://schemas.openxmlformats.org/drawingml/2006/table">
@@ -10677,7 +11160,7 @@
                   </a:extLst>
                 </a:gridCol>
               </a:tblGrid>
-              <a:tr h="346022">
+              <a:tr h="300128">
                 <a:tc>
                   <a:txBody>
                     <a:bodyPr/>
@@ -10788,7 +11271,7 @@
                   </a:ext>
                 </a:extLst>
               </a:tr>
-              <a:tr h="1008242">
+              <a:tr h="948655">
                 <a:tc>
                   <a:txBody>
                     <a:bodyPr/>
@@ -11118,7 +11601,7 @@
                   </a:ext>
                 </a:extLst>
               </a:tr>
-              <a:tr h="838200">
+              <a:tr h="948655">
                 <a:tc rowSpan="2">
                   <a:txBody>
                     <a:bodyPr/>
@@ -11292,7 +11775,7 @@
                   </a:ext>
                 </a:extLst>
               </a:tr>
-              <a:tr h="806146">
+              <a:tr h="699223">
                 <a:tc vMerge="1">
                   <a:txBody>
                     <a:bodyPr/>
@@ -11403,7 +11886,7 @@
                   </a:ext>
                 </a:extLst>
               </a:tr>
-              <a:tr h="724754">
+              <a:tr h="713502">
                 <a:tc rowSpan="2">
                   <a:txBody>
                     <a:bodyPr/>
@@ -11564,7 +12047,7 @@
                   </a:ext>
                 </a:extLst>
               </a:tr>
-              <a:tr h="594494">
+              <a:tr h="515644">
                 <a:tc vMerge="1">
                   <a:txBody>
                     <a:bodyPr/>
@@ -11675,7 +12158,7 @@
                   </a:ext>
                 </a:extLst>
               </a:tr>
-              <a:tr h="1074861">
+              <a:tr h="2829878">
                 <a:tc>
                   <a:txBody>
                     <a:bodyPr/>

</xml_diff>